<commit_message>
Regenerate report and slide artifacts
</commit_message>
<xml_diff>
--- a/slides/slides-knight-chaos-cipher.pptx
+++ b/slides/slides-knight-chaos-cipher.pptx
@@ -19,6 +19,8 @@
     <p:sldId id="267" r:id="rId13"/>
     <p:sldId id="268" r:id="rId14"/>
     <p:sldId id="269" r:id="rId15"/>
+    <p:sldId id="270" r:id="rId16"/>
+    <p:sldId id="271" r:id="rId17"/>
   </p:sldIdLst>
   <p:sldSz cx="9144000" cy="5143500" type="screen16x9"/>
   <p:notesSz cx="6858000" cy="9144000"/>
@@ -3226,7 +3228,12 @@
             <p:ph type="title"/>
           </p:nvPr>
         </p:nvSpPr>
-        <p:spPr/>
+        <p:spPr>
+          <a:xfrm>
+            <a:off x="457201" y="204787"/>
+            <a:ext cx="3008313" cy="871538"/>
+          </a:xfrm>
+        </p:spPr>
         <p:txBody>
           <a:bodyPr/>
           <a:lstStyle/>
@@ -3236,55 +3243,198 @@
             </a:pPr>
             <a:r>
               <a:rPr/>
-              <a:t>Analisis Keamanan Awal</a:t>
-            </a:r>
-          </a:p>
-        </p:txBody>
-      </p:sp>
-      <p:sp>
-        <p:nvSpPr>
-          <p:cNvPr id="3" name="Content Placeholder 2"/>
-          <p:cNvSpPr>
-            <a:spLocks noGrp="1"/>
-          </p:cNvSpPr>
+              <a:t>Hasil Sample Run</a:t>
+            </a:r>
+          </a:p>
+        </p:txBody>
+      </p:sp>
+      <p:sp>
+        <p:nvSpPr>
+          <p:cNvPr id="4" name="Text Placeholder 3"/>
+          <p:cNvSpPr>
+            <a:spLocks noGrp="1"/>
+          </p:cNvSpPr>
+          <p:nvPr>
+            <p:ph idx="2" sz="half" type="body"/>
+          </p:nvPr>
+        </p:nvSpPr>
+        <p:spPr/>
+        <p:txBody>
+          <a:bodyPr/>
+          <a:lstStyle/>
+          <a:p>
+            <a:pPr lvl="0" indent="0">
+              <a:buNone/>
+            </a:pPr>
+            <a:r>
+              <a:rPr>
+                <a:latin typeface="Courier"/>
+              </a:rPr>
+              <a:t>Plaintext:  "Cyber Security Tugas 3: ..."
+Key:        "KCC-24.55.2714-Muhammad-Rizky-Hajar"
+Decryption: OK ✓</a:t>
+            </a:r>
+          </a:p>
+        </p:txBody>
+      </p:sp>
+      <p:graphicFrame>
+        <p:nvGraphicFramePr>
+          <p:cNvPr id="6" name="Content Placeholder 5"/>
+          <p:cNvGraphicFramePr>
+            <a:graphicFrameLocks noGrp="1"/>
+          </p:cNvGraphicFramePr>
           <p:nvPr>
             <p:ph idx="1"/>
           </p:nvPr>
-        </p:nvSpPr>
-        <p:spPr/>
-        <p:txBody>
-          <a:bodyPr/>
-          <a:lstStyle/>
-          <a:p>
-            <a:pPr lvl="0"/>
-            <a:r>
-              <a:rPr/>
-              <a:t>Entropy plaintext: sekitar 4.3846 bit/byte.</a:t>
-            </a:r>
-          </a:p>
-          <a:p>
-            <a:pPr lvl="0"/>
-            <a:r>
-              <a:rPr/>
-              <a:t>Entropy ciphertext: sekitar 6.6660 bit/byte.</a:t>
-            </a:r>
-          </a:p>
-          <a:p>
-            <a:pPr lvl="0"/>
-            <a:r>
-              <a:rPr/>
-              <a:t>Avalanche effect: sekitar 48.34%.</a:t>
-            </a:r>
-          </a:p>
-          <a:p>
-            <a:pPr lvl="0"/>
-            <a:r>
-              <a:rPr/>
-              <a:t>Frekuensi byte ciphertext lebih tersebar daripada plaintext.</a:t>
-            </a:r>
-          </a:p>
-        </p:txBody>
-      </p:sp>
+        </p:nvGraphicFramePr>
+        <p:xfrm>
+          <a:off x="3568700" y="203200"/>
+          <a:ext cx="5105400" cy="4381500"/>
+        </p:xfrm>
+        <a:graphic>
+          <a:graphicData uri="http://schemas.openxmlformats.org/drawingml/2006/table">
+            <a:tbl>
+              <a:tblPr firstRow="1" bandRow="1">
+                <a:tableStyleId>{5C22544A-7EE6-4342-B048-85BDC9FD1C3A}</a:tableStyleId>
+              </a:tblPr>
+              <a:tblGrid>
+                <a:gridCol w="2552700"/>
+                <a:gridCol w="2552700"/>
+              </a:tblGrid>
+              <a:tr h="0">
+                <a:tc>
+                  <a:txBody>
+                    <a:bodyPr/>
+                    <a:lstStyle/>
+                    <a:p>
+                      <a:pPr lvl="0" indent="0" marL="0">
+                        <a:buNone/>
+                      </a:pPr>
+                      <a:r>
+                        <a:rPr/>
+                        <a:t>Metrik</a:t>
+                      </a:r>
+                    </a:p>
+                  </a:txBody>
+                  <a:tcPr/>
+                </a:tc>
+                <a:tc>
+                  <a:txBody>
+                    <a:bodyPr/>
+                    <a:lstStyle/>
+                    <a:p>
+                      <a:pPr lvl="0" indent="0" marL="0">
+                        <a:buNone/>
+                      </a:pPr>
+                      <a:r>
+                        <a:rPr/>
+                        <a:t>Nilai</a:t>
+                      </a:r>
+                    </a:p>
+                  </a:txBody>
+                  <a:tcPr/>
+                </a:tc>
+              </a:tr>
+              <a:tr h="0">
+                <a:tc>
+                  <a:txBody>
+                    <a:bodyPr/>
+                    <a:lstStyle/>
+                    <a:p>
+                      <a:pPr lvl="0" indent="0" marL="0">
+                        <a:buNone/>
+                      </a:pPr>
+                      <a:r>
+                        <a:rPr/>
+                        <a:t>Plaintext entropy</a:t>
+                      </a:r>
+                    </a:p>
+                  </a:txBody>
+                </a:tc>
+                <a:tc>
+                  <a:txBody>
+                    <a:bodyPr/>
+                    <a:lstStyle/>
+                    <a:p>
+                      <a:pPr lvl="0" indent="0" marL="0">
+                        <a:buNone/>
+                      </a:pPr>
+                      <a:r>
+                        <a:rPr/>
+                        <a:t>~4.40 bit/byte</a:t>
+                      </a:r>
+                    </a:p>
+                  </a:txBody>
+                </a:tc>
+              </a:tr>
+              <a:tr h="0">
+                <a:tc>
+                  <a:txBody>
+                    <a:bodyPr/>
+                    <a:lstStyle/>
+                    <a:p>
+                      <a:pPr lvl="0" indent="0" marL="0">
+                        <a:buNone/>
+                      </a:pPr>
+                      <a:r>
+                        <a:rPr/>
+                        <a:t>Ciphertext entropy</a:t>
+                      </a:r>
+                    </a:p>
+                  </a:txBody>
+                </a:tc>
+                <a:tc>
+                  <a:txBody>
+                    <a:bodyPr/>
+                    <a:lstStyle/>
+                    <a:p>
+                      <a:pPr lvl="0" indent="0" marL="0">
+                        <a:buNone/>
+                      </a:pPr>
+                      <a:r>
+                        <a:rPr/>
+                        <a:t>~6.63 bit/byte</a:t>
+                      </a:r>
+                    </a:p>
+                  </a:txBody>
+                </a:tc>
+              </a:tr>
+              <a:tr h="0">
+                <a:tc>
+                  <a:txBody>
+                    <a:bodyPr/>
+                    <a:lstStyle/>
+                    <a:p>
+                      <a:pPr lvl="0" indent="0" marL="0">
+                        <a:buNone/>
+                      </a:pPr>
+                      <a:r>
+                        <a:rPr/>
+                        <a:t>Avalanche effect</a:t>
+                      </a:r>
+                    </a:p>
+                  </a:txBody>
+                </a:tc>
+                <a:tc>
+                  <a:txBody>
+                    <a:bodyPr/>
+                    <a:lstStyle/>
+                    <a:p>
+                      <a:pPr lvl="0" indent="0" marL="0">
+                        <a:buNone/>
+                      </a:pPr>
+                      <a:r>
+                        <a:rPr/>
+                        <a:t>~50.29%</a:t>
+                      </a:r>
+                    </a:p>
+                  </a:txBody>
+                </a:tc>
+              </a:tr>
+            </a:tbl>
+          </a:graphicData>
+        </a:graphic>
+      </p:graphicFrame>
     </p:spTree>
   </p:cSld>
 </p:sld>
@@ -3327,7 +3477,7 @@
             </a:pPr>
             <a:r>
               <a:rPr/>
-              <a:t>Demo Interaktif</a:t>
+              <a:t>Analisis Keamanan</a:t>
             </a:r>
           </a:p>
         </p:txBody>
@@ -3349,42 +3499,45 @@
           <a:p>
             <a:pPr lvl="0"/>
             <a:r>
-              <a:rPr/>
-              <a:t>File: </a:t>
-            </a:r>
-            <a:r>
-              <a:rPr>
-                <a:latin typeface="Courier"/>
-              </a:rPr>
-              <a:t>demo/index.html</a:t>
+              <a:rPr b="1"/>
+              <a:t>Entropy:</a:t>
+            </a:r>
+            <a:r>
+              <a:rPr/>
+              <a:t> naik dari 4.40 → 6.63 bit/byte (lebih uniform).</a:t>
             </a:r>
           </a:p>
           <a:p>
             <a:pPr lvl="0"/>
             <a:r>
-              <a:rPr/>
-              <a:t>Visualisasi matriks state 4x4.</a:t>
+              <a:rPr b="1"/>
+              <a:t>Avalanche:</a:t>
+            </a:r>
+            <a:r>
+              <a:rPr/>
+              <a:t> ~50% — ubah 1 bit input, ~setengah bit output berubah.</a:t>
             </a:r>
           </a:p>
           <a:p>
             <a:pPr lvl="0"/>
             <a:r>
-              <a:rPr/>
-              <a:t>Timeline setiap step round.</a:t>
+              <a:rPr b="1"/>
+              <a:t>Frequency:</a:t>
+            </a:r>
+            <a:r>
+              <a:rPr/>
+              <a:t> tidak ada byte value yang dominan pada ciphertext.</a:t>
             </a:r>
           </a:p>
           <a:p>
             <a:pPr lvl="0"/>
             <a:r>
-              <a:rPr/>
-              <a:t>Tombol Encrypt, Prev, Play, dan Next.</a:t>
-            </a:r>
-          </a:p>
-          <a:p>
-            <a:pPr lvl="0"/>
-            <a:r>
-              <a:rPr/>
-              <a:t>Menunjukkan perubahan state secara bertahap.</a:t>
+              <a:rPr b="1"/>
+              <a:t>vs. Caesar/Vigenere:</a:t>
+            </a:r>
+            <a:r>
+              <a:rPr/>
+              <a:t> KCC-128 memutus hubungan langsung plaintext–ciphertext melalui non-linear S-Box + permutation + diffusion.</a:t>
             </a:r>
           </a:p>
         </p:txBody>
@@ -3431,7 +3584,7 @@
             </a:pPr>
             <a:r>
               <a:rPr/>
-              <a:t>Keterbatasan</a:t>
+              <a:t>Demo Interaktif</a:t>
             </a:r>
           </a:p>
         </p:txBody>
@@ -3454,28 +3607,68 @@
             <a:pPr lvl="0"/>
             <a:r>
               <a:rPr/>
-              <a:t>Pengujian dapat diperluas dengan dataset plaintext lebih besar.</a:t>
+              <a:t>File: </a:t>
+            </a:r>
+            <a:r>
+              <a:rPr>
+                <a:latin typeface="Courier"/>
+              </a:rPr>
+              <a:t>demo/index.html</a:t>
             </a:r>
           </a:p>
           <a:p>
             <a:pPr lvl="0"/>
             <a:r>
-              <a:rPr/>
-              <a:t>IV acak dapat ditambahkan untuk mode operasional lanjutan.</a:t>
+              <a:rPr b="1"/>
+              <a:t>Block selector</a:t>
+            </a:r>
+            <a:r>
+              <a:rPr/>
+              <a:t> — pilih block mana yang mau dilihat.</a:t>
             </a:r>
           </a:p>
           <a:p>
             <a:pPr lvl="0"/>
             <a:r>
-              <a:rPr/>
-              <a:t>Analisis lanjutan dapat mencakup linear/differential cryptanalysis.</a:t>
+              <a:rPr b="1"/>
+              <a:t>Matrix 4×4</a:t>
+            </a:r>
+            <a:r>
+              <a:rPr/>
+              <a:t> — klik cell untuk lihat hitung manual byte tersebut.</a:t>
             </a:r>
           </a:p>
           <a:p>
             <a:pPr lvl="0"/>
             <a:r>
-              <a:rPr/>
-              <a:t>Struktur round memberi ruang optimasi parameter.</a:t>
+              <a:rPr b="1"/>
+              <a:t>Detail panel</a:t>
+            </a:r>
+            <a:r>
+              <a:rPr/>
+              <a:t> — menampilkan XOR biner, S-Box lookup, rotation, per byte.</a:t>
+            </a:r>
+          </a:p>
+          <a:p>
+            <a:pPr lvl="0"/>
+            <a:r>
+              <a:rPr b="1"/>
+              <a:t>Assembly view</a:t>
+            </a:r>
+            <a:r>
+              <a:rPr/>
+              <a:t> — menampilkan bagaimana block-block digabung jadi ciphertext final.</a:t>
+            </a:r>
+          </a:p>
+          <a:p>
+            <a:pPr lvl="0"/>
+            <a:r>
+              <a:rPr b="1"/>
+              <a:t>Timeline</a:t>
+            </a:r>
+            <a:r>
+              <a:rPr/>
+              <a:t> — navigasi step-by-step per round.</a:t>
             </a:r>
           </a:p>
         </p:txBody>
@@ -3522,7 +3715,7 @@
             </a:pPr>
             <a:r>
               <a:rPr/>
-              <a:t>Kesimpulan</a:t>
+              <a:t>Fitur Demo</a:t>
             </a:r>
           </a:p>
         </p:txBody>
@@ -3542,31 +3735,48 @@
           <a:bodyPr/>
           <a:lstStyle/>
           <a:p>
-            <a:pPr lvl="0"/>
-            <a:r>
-              <a:rPr/>
-              <a:t>KCC-128 menambahkan ide baru pada arsitektur cipher.</a:t>
-            </a:r>
-          </a:p>
-          <a:p>
-            <a:pPr lvl="0"/>
-            <a:r>
-              <a:rPr/>
-              <a:t>Game logic digunakan sebagai permutasi.</a:t>
-            </a:r>
-          </a:p>
-          <a:p>
-            <a:pPr lvl="0"/>
-            <a:r>
-              <a:rPr/>
-              <a:t>Chaotic map digunakan sebagai S-Box dinamis.</a:t>
-            </a:r>
-          </a:p>
-          <a:p>
-            <a:pPr lvl="0"/>
-            <a:r>
-              <a:rPr/>
-              <a:t>Implementasi berhasil dan dapat didemonstrasikan langsung.</a:t>
+            <a:pPr lvl="0" indent="-342900" marL="342900">
+              <a:buAutoNum type="arabicPeriod"/>
+            </a:pPr>
+            <a:r>
+              <a:rPr/>
+              <a:t>Konversi plaintext → byte (tabel ASCII lengkap)</a:t>
+            </a:r>
+          </a:p>
+          <a:p>
+            <a:pPr lvl="0" indent="-342900" marL="342900">
+              <a:buAutoNum type="arabicPeriod"/>
+            </a:pPr>
+            <a:r>
+              <a:rPr/>
+              <a:t>Hitung manual per byte (dynamic, klik cell manapun)</a:t>
+            </a:r>
+          </a:p>
+          <a:p>
+            <a:pPr lvl="0" indent="-342900" marL="342900">
+              <a:buAutoNum type="arabicPeriod"/>
+            </a:pPr>
+            <a:r>
+              <a:rPr/>
+              <a:t>Visualisasi round key, S-Box mapping, knight path</a:t>
+            </a:r>
+          </a:p>
+          <a:p>
+            <a:pPr lvl="0" indent="-342900" marL="342900">
+              <a:buAutoNum type="arabicPeriod"/>
+            </a:pPr>
+            <a:r>
+              <a:rPr/>
+              <a:t>Block selector untuk multi-block plaintext</a:t>
+            </a:r>
+          </a:p>
+          <a:p>
+            <a:pPr lvl="0" indent="-342900" marL="342900">
+              <a:buAutoNum type="arabicPeriod"/>
+            </a:pPr>
+            <a:r>
+              <a:rPr/>
+              <a:t>Concat visualization: block 1 + block 2 + … = ciphertext</a:t>
             </a:r>
           </a:p>
         </p:txBody>
@@ -3613,6 +3823,195 @@
             </a:pPr>
             <a:r>
               <a:rPr/>
+              <a:t>Keterbatasan</a:t>
+            </a:r>
+          </a:p>
+        </p:txBody>
+      </p:sp>
+      <p:sp>
+        <p:nvSpPr>
+          <p:cNvPr id="3" name="Content Placeholder 2"/>
+          <p:cNvSpPr>
+            <a:spLocks noGrp="1"/>
+          </p:cNvSpPr>
+          <p:nvPr>
+            <p:ph idx="1"/>
+          </p:nvPr>
+        </p:nvSpPr>
+        <p:spPr/>
+        <p:txBody>
+          <a:bodyPr/>
+          <a:lstStyle/>
+          <a:p>
+            <a:pPr lvl="0"/>
+            <a:r>
+              <a:rPr/>
+              <a:t>IV di-derive deterministic dari key (idealnya random).</a:t>
+            </a:r>
+          </a:p>
+          <a:p>
+            <a:pPr lvl="0"/>
+            <a:r>
+              <a:rPr/>
+              <a:t>Belum ada MAC/HMAC (hanya confidentiality, belum integrity).</a:t>
+            </a:r>
+          </a:p>
+          <a:p>
+            <a:pPr lvl="0"/>
+            <a:r>
+              <a:rPr/>
+              <a:t>S-Box nonlinearity dan differential uniformity belum diuji formal.</a:t>
+            </a:r>
+          </a:p>
+          <a:p>
+            <a:pPr lvl="0"/>
+            <a:r>
+              <a:rPr/>
+              <a:t>Pengujian perlu diperluas dengan dataset yang lebih besar.</a:t>
+            </a:r>
+          </a:p>
+        </p:txBody>
+      </p:sp>
+    </p:spTree>
+  </p:cSld>
+</p:sld>
+</file>
+
+<file path=ppt/slides/slide15.xml><?xml version="1.0" encoding="utf-8"?>
+<p:sld xmlns:a="http://schemas.openxmlformats.org/drawingml/2006/main" xmlns:r="http://schemas.openxmlformats.org/officeDocument/2006/relationships" xmlns:p="http://schemas.openxmlformats.org/presentationml/2006/main">
+  <p:cSld>
+    <p:spTree>
+      <p:nvGrpSpPr>
+        <p:cNvPr id="1" name=""/>
+        <p:cNvGrpSpPr/>
+        <p:nvPr/>
+      </p:nvGrpSpPr>
+      <p:grpSpPr>
+        <a:xfrm>
+          <a:off x="0" y="0"/>
+          <a:ext cx="0" cy="0"/>
+          <a:chOff x="0" y="0"/>
+          <a:chExt cx="0" cy="0"/>
+        </a:xfrm>
+      </p:grpSpPr>
+      <p:sp>
+        <p:nvSpPr>
+          <p:cNvPr id="2" name="Title 1"/>
+          <p:cNvSpPr>
+            <a:spLocks noGrp="1"/>
+          </p:cNvSpPr>
+          <p:nvPr>
+            <p:ph type="title"/>
+          </p:nvPr>
+        </p:nvSpPr>
+        <p:spPr/>
+        <p:txBody>
+          <a:bodyPr/>
+          <a:lstStyle/>
+          <a:p>
+            <a:pPr lvl="0" indent="0" marL="0">
+              <a:buNone/>
+            </a:pPr>
+            <a:r>
+              <a:rPr/>
+              <a:t>Kesimpulan</a:t>
+            </a:r>
+          </a:p>
+        </p:txBody>
+      </p:sp>
+      <p:sp>
+        <p:nvSpPr>
+          <p:cNvPr id="3" name="Content Placeholder 2"/>
+          <p:cNvSpPr>
+            <a:spLocks noGrp="1"/>
+          </p:cNvSpPr>
+          <p:nvPr>
+            <p:ph idx="1"/>
+          </p:nvPr>
+        </p:nvSpPr>
+        <p:spPr/>
+        <p:txBody>
+          <a:bodyPr/>
+          <a:lstStyle/>
+          <a:p>
+            <a:pPr lvl="0"/>
+            <a:r>
+              <a:rPr/>
+              <a:t>KCC-128 memodifikasi substitution, permutation, diffusion, dan key schedule.</a:t>
+            </a:r>
+          </a:p>
+          <a:p>
+            <a:pPr lvl="0"/>
+            <a:r>
+              <a:rPr/>
+              <a:t>Knight’s tour sebagai permutation → non-linear, game-based.</a:t>
+            </a:r>
+          </a:p>
+          <a:p>
+            <a:pPr lvl="0"/>
+            <a:r>
+              <a:rPr/>
+              <a:t>Chaotic map sebagai S-Box generator → dynamic per round.</a:t>
+            </a:r>
+          </a:p>
+          <a:p>
+            <a:pPr lvl="0"/>
+            <a:r>
+              <a:rPr/>
+              <a:t>Encryption-decryption bekerja benar, avalanche ~50%.</a:t>
+            </a:r>
+          </a:p>
+          <a:p>
+            <a:pPr lvl="0"/>
+            <a:r>
+              <a:rPr/>
+              <a:t>Demo interaktif menampilkan proses manual step-by-step.</a:t>
+            </a:r>
+          </a:p>
+        </p:txBody>
+      </p:sp>
+    </p:spTree>
+  </p:cSld>
+</p:sld>
+</file>
+
+<file path=ppt/slides/slide16.xml><?xml version="1.0" encoding="utf-8"?>
+<p:sld xmlns:a="http://schemas.openxmlformats.org/drawingml/2006/main" xmlns:r="http://schemas.openxmlformats.org/officeDocument/2006/relationships" xmlns:p="http://schemas.openxmlformats.org/presentationml/2006/main">
+  <p:cSld>
+    <p:spTree>
+      <p:nvGrpSpPr>
+        <p:cNvPr id="1" name=""/>
+        <p:cNvGrpSpPr/>
+        <p:nvPr/>
+      </p:nvGrpSpPr>
+      <p:grpSpPr>
+        <a:xfrm>
+          <a:off x="0" y="0"/>
+          <a:ext cx="0" cy="0"/>
+          <a:chOff x="0" y="0"/>
+          <a:chExt cx="0" cy="0"/>
+        </a:xfrm>
+      </p:grpSpPr>
+      <p:sp>
+        <p:nvSpPr>
+          <p:cNvPr id="2" name="Title 1"/>
+          <p:cNvSpPr>
+            <a:spLocks noGrp="1"/>
+          </p:cNvSpPr>
+          <p:nvPr>
+            <p:ph type="title"/>
+          </p:nvPr>
+        </p:nvSpPr>
+        <p:spPr/>
+        <p:txBody>
+          <a:bodyPr/>
+          <a:lstStyle/>
+          <a:p>
+            <a:pPr lvl="0" indent="0" marL="0">
+              <a:buNone/>
+            </a:pPr>
+            <a:r>
+              <a:rPr/>
               <a:t>Live Demo</a:t>
             </a:r>
           </a:p>
@@ -3632,25 +4031,6 @@
         <p:txBody>
           <a:bodyPr/>
           <a:lstStyle/>
-          <a:p>
-            <a:pPr lvl="0" indent="-342900" marL="342900">
-              <a:buAutoNum type="arabicPeriod"/>
-            </a:pPr>
-            <a:r>
-              <a:rPr/>
-              <a:t>Jalankan </a:t>
-            </a:r>
-            <a:r>
-              <a:rPr>
-                <a:latin typeface="Courier"/>
-              </a:rPr>
-              <a:t>python3 src/demo.py</a:t>
-            </a:r>
-            <a:r>
-              <a:rPr/>
-              <a:t>.</a:t>
-            </a:r>
-          </a:p>
           <a:p>
             <a:pPr lvl="0" indent="-342900" marL="342900">
               <a:buAutoNum type="arabicPeriod"/>
@@ -3667,7 +4047,7 @@
             </a:r>
             <a:r>
               <a:rPr/>
-              <a:t>.</a:t>
+              <a:t> di browser.</a:t>
             </a:r>
           </a:p>
           <a:p>
@@ -3676,17 +4056,7 @@
             </a:pPr>
             <a:r>
               <a:rPr/>
-              <a:t>Klik </a:t>
-            </a:r>
-            <a:r>
-              <a:rPr>
-                <a:latin typeface="Courier"/>
-              </a:rPr>
-              <a:t>Encrypt &amp; Animate</a:t>
-            </a:r>
-            <a:r>
-              <a:rPr/>
-              <a:t>.</a:t>
+              <a:t>Masukkan plaintext dan key.</a:t>
             </a:r>
           </a:p>
           <a:p>
@@ -3695,7 +4065,50 @@
             </a:pPr>
             <a:r>
               <a:rPr/>
-              <a:t>Tunjukkan ciphertext, decryption check, dan timeline round.</a:t>
+              <a:t>Klik </a:t>
+            </a:r>
+            <a:r>
+              <a:rPr b="1"/>
+              <a:t>Encrypt &amp; Animate</a:t>
+            </a:r>
+            <a:r>
+              <a:rPr/>
+              <a:t>.</a:t>
+            </a:r>
+          </a:p>
+          <a:p>
+            <a:pPr lvl="0" indent="-342900" marL="342900">
+              <a:buAutoNum type="arabicPeriod"/>
+            </a:pPr>
+            <a:r>
+              <a:rPr/>
+              <a:t>Pilih block dari dropdown.</a:t>
+            </a:r>
+          </a:p>
+          <a:p>
+            <a:pPr lvl="0" indent="-342900" marL="342900">
+              <a:buAutoNum type="arabicPeriod"/>
+            </a:pPr>
+            <a:r>
+              <a:rPr/>
+              <a:t>Klik cell di matrix → lihat hitung manual.</a:t>
+            </a:r>
+          </a:p>
+          <a:p>
+            <a:pPr lvl="0" indent="-342900" marL="342900">
+              <a:buAutoNum type="arabicPeriod"/>
+            </a:pPr>
+            <a:r>
+              <a:rPr/>
+              <a:t>Navigasi step dengan </a:t>
+            </a:r>
+            <a:r>
+              <a:rPr b="1"/>
+              <a:t>Prev / Play / Next</a:t>
+            </a:r>
+            <a:r>
+              <a:rPr/>
+              <a:t>.</a:t>
             </a:r>
           </a:p>
         </p:txBody>
@@ -3786,7 +4199,7 @@
             <a:pPr lvl="0"/>
             <a:r>
               <a:rPr/>
-              <a:t>Target: enkripsi, dekripsi, demo, dan analisis keamanan.</a:t>
+              <a:t>Target: encryption, decryption, demo, dan analisis keamanan.</a:t>
             </a:r>
           </a:p>
         </p:txBody>
@@ -3865,35 +4278,35 @@
             <a:pPr lvl="0"/>
             <a:r>
               <a:rPr/>
-              <a:t>Block cipher 128 bit.</a:t>
+              <a:t>Block cipher 128 bit (16 byte per block).</a:t>
             </a:r>
           </a:p>
           <a:p>
             <a:pPr lvl="0"/>
             <a:r>
               <a:rPr/>
-              <a:t>10 round transformasi.</a:t>
+              <a:t>10 round transformation.</a:t>
             </a:r>
           </a:p>
           <a:p>
             <a:pPr lvl="0"/>
             <a:r>
               <a:rPr/>
-              <a:t>Papan 4x4 mewakili 16 byte.</a:t>
+              <a:t>Board 4×4 merepresentasikan 16 byte.</a:t>
             </a:r>
           </a:p>
           <a:p>
             <a:pPr lvl="0"/>
             <a:r>
               <a:rPr/>
-              <a:t>Langkah kuda catur menjadi permutasi internal.</a:t>
+              <a:t>Knight’s tour menjadi permutation internal.</a:t>
             </a:r>
           </a:p>
           <a:p>
             <a:pPr lvl="0"/>
             <a:r>
               <a:rPr/>
-              <a:t>Logistic chaotic map membentuk S-Box dinamis.</a:t>
+              <a:t>Logistic chaotic map men-generate dynamic S-Box per round.</a:t>
             </a:r>
           </a:p>
         </p:txBody>
@@ -3945,50 +4358,226 @@
           </a:p>
         </p:txBody>
       </p:sp>
-      <p:sp>
-        <p:nvSpPr>
-          <p:cNvPr id="3" name="Content Placeholder 2"/>
-          <p:cNvSpPr>
-            <a:spLocks noGrp="1"/>
-          </p:cNvSpPr>
+      <p:graphicFrame>
+        <p:nvGraphicFramePr>
+          <p:cNvPr id="6" name="Content Placeholder 5"/>
+          <p:cNvGraphicFramePr>
+            <a:graphicFrameLocks noGrp="1"/>
+          </p:cNvGraphicFramePr>
           <p:nvPr>
             <p:ph idx="1"/>
           </p:nvPr>
-        </p:nvSpPr>
-        <p:spPr/>
-        <p:txBody>
-          <a:bodyPr/>
-          <a:lstStyle/>
-          <a:p>
-            <a:pPr lvl="0"/>
-            <a:r>
-              <a:rPr/>
-              <a:t>KCC membuat S-Box per round dari chaotic map.</a:t>
-            </a:r>
-          </a:p>
-          <a:p>
-            <a:pPr lvl="0"/>
-            <a:r>
-              <a:rPr/>
-              <a:t>Rute langkah kuda catur digunakan sebagai permutasi.</a:t>
-            </a:r>
-          </a:p>
-          <a:p>
-            <a:pPr lvl="0"/>
-            <a:r>
-              <a:rPr/>
-              <a:t>Key schedule menghasilkan XOR key dan parameter struktur round.</a:t>
-            </a:r>
-          </a:p>
-          <a:p>
-            <a:pPr lvl="0"/>
-            <a:r>
-              <a:rPr/>
-              <a:t>Kunci ikut mengubah S-Box, rute kuda, rotasi bit, dan difusi.</a:t>
-            </a:r>
-          </a:p>
-        </p:txBody>
-      </p:sp>
+        </p:nvGraphicFramePr>
+        <p:xfrm>
+          <a:off x="457200" y="1193800"/>
+          <a:ext cx="8229600" cy="3390900"/>
+        </p:xfrm>
+        <a:graphic>
+          <a:graphicData uri="http://schemas.openxmlformats.org/drawingml/2006/table">
+            <a:tbl>
+              <a:tblPr firstRow="1" bandRow="1">
+                <a:tableStyleId>{5C22544A-7EE6-4342-B048-85BDC9FD1C3A}</a:tableStyleId>
+              </a:tblPr>
+              <a:tblGrid>
+                <a:gridCol w="3429000"/>
+                <a:gridCol w="1714500"/>
+                <a:gridCol w="3086100"/>
+              </a:tblGrid>
+              <a:tr h="0">
+                <a:tc>
+                  <a:txBody>
+                    <a:bodyPr/>
+                    <a:lstStyle/>
+                    <a:p>
+                      <a:pPr lvl="0" indent="0" marL="0">
+                        <a:buNone/>
+                      </a:pPr>
+                      <a:r>
+                        <a:rPr/>
+                        <a:t>Komponen</a:t>
+                      </a:r>
+                    </a:p>
+                  </a:txBody>
+                  <a:tcPr/>
+                </a:tc>
+                <a:tc>
+                  <a:txBody>
+                    <a:bodyPr/>
+                    <a:lstStyle/>
+                    <a:p>
+                      <a:pPr lvl="0" indent="0" marL="0">
+                        <a:buNone/>
+                      </a:pPr>
+                      <a:r>
+                        <a:rPr/>
+                        <a:t>AES</a:t>
+                      </a:r>
+                    </a:p>
+                  </a:txBody>
+                  <a:tcPr/>
+                </a:tc>
+                <a:tc>
+                  <a:txBody>
+                    <a:bodyPr/>
+                    <a:lstStyle/>
+                    <a:p>
+                      <a:pPr lvl="0" indent="0" marL="0">
+                        <a:buNone/>
+                      </a:pPr>
+                      <a:r>
+                        <a:rPr/>
+                        <a:t>KCC-128</a:t>
+                      </a:r>
+                    </a:p>
+                  </a:txBody>
+                  <a:tcPr/>
+                </a:tc>
+              </a:tr>
+              <a:tr h="0">
+                <a:tc>
+                  <a:txBody>
+                    <a:bodyPr/>
+                    <a:lstStyle/>
+                    <a:p>
+                      <a:pPr lvl="0" indent="0" marL="0">
+                        <a:buNone/>
+                      </a:pPr>
+                      <a:r>
+                        <a:rPr/>
+                        <a:t>S-Box</a:t>
+                      </a:r>
+                    </a:p>
+                  </a:txBody>
+                </a:tc>
+                <a:tc>
+                  <a:txBody>
+                    <a:bodyPr/>
+                    <a:lstStyle/>
+                    <a:p>
+                      <a:pPr lvl="0" indent="0" marL="0">
+                        <a:buNone/>
+                      </a:pPr>
+                      <a:r>
+                        <a:rPr/>
+                        <a:t>Tetap (1 untuk semua round)</a:t>
+                      </a:r>
+                    </a:p>
+                  </a:txBody>
+                </a:tc>
+                <a:tc>
+                  <a:txBody>
+                    <a:bodyPr/>
+                    <a:lstStyle/>
+                    <a:p>
+                      <a:pPr lvl="0" indent="0" marL="0">
+                        <a:buNone/>
+                      </a:pPr>
+                      <a:r>
+                        <a:rPr/>
+                        <a:t>Dynamic, berubah tiap round (chaotic map)</a:t>
+                      </a:r>
+                    </a:p>
+                  </a:txBody>
+                </a:tc>
+              </a:tr>
+              <a:tr h="0">
+                <a:tc>
+                  <a:txBody>
+                    <a:bodyPr/>
+                    <a:lstStyle/>
+                    <a:p>
+                      <a:pPr lvl="0" indent="0" marL="0">
+                        <a:buNone/>
+                      </a:pPr>
+                      <a:r>
+                        <a:rPr/>
+                        <a:t>Permutation</a:t>
+                      </a:r>
+                    </a:p>
+                  </a:txBody>
+                </a:tc>
+                <a:tc>
+                  <a:txBody>
+                    <a:bodyPr/>
+                    <a:lstStyle/>
+                    <a:p>
+                      <a:pPr lvl="0" indent="0" marL="0">
+                        <a:buNone/>
+                      </a:pPr>
+                      <a:r>
+                        <a:rPr/>
+                        <a:t>ShiftRows (linear shift)</a:t>
+                      </a:r>
+                    </a:p>
+                  </a:txBody>
+                </a:tc>
+                <a:tc>
+                  <a:txBody>
+                    <a:bodyPr/>
+                    <a:lstStyle/>
+                    <a:p>
+                      <a:pPr lvl="0" indent="0" marL="0">
+                        <a:buNone/>
+                      </a:pPr>
+                      <a:r>
+                        <a:rPr/>
+                        <a:t>Knight’s tour (non-linear, L-shape)</a:t>
+                      </a:r>
+                    </a:p>
+                  </a:txBody>
+                </a:tc>
+              </a:tr>
+              <a:tr h="0">
+                <a:tc>
+                  <a:txBody>
+                    <a:bodyPr/>
+                    <a:lstStyle/>
+                    <a:p>
+                      <a:pPr lvl="0" indent="0" marL="0">
+                        <a:buNone/>
+                      </a:pPr>
+                      <a:r>
+                        <a:rPr/>
+                        <a:t>Key Schedule</a:t>
+                      </a:r>
+                    </a:p>
+                  </a:txBody>
+                </a:tc>
+                <a:tc>
+                  <a:txBody>
+                    <a:bodyPr/>
+                    <a:lstStyle/>
+                    <a:p>
+                      <a:pPr lvl="0" indent="0" marL="0">
+                        <a:buNone/>
+                      </a:pPr>
+                      <a:r>
+                        <a:rPr/>
+                        <a:t>Menghasilkan round key saja</a:t>
+                      </a:r>
+                    </a:p>
+                  </a:txBody>
+                </a:tc>
+                <a:tc>
+                  <a:txBody>
+                    <a:bodyPr/>
+                    <a:lstStyle/>
+                    <a:p>
+                      <a:pPr lvl="0" indent="0" marL="0">
+                        <a:buNone/>
+                      </a:pPr>
+                      <a:r>
+                        <a:rPr/>
+                        <a:t>Mengubah S-Box, route, rotation, diffusion</a:t>
+                      </a:r>
+                    </a:p>
+                  </a:txBody>
+                </a:tc>
+              </a:tr>
+            </a:tbl>
+          </a:graphicData>
+        </a:graphic>
+      </p:graphicFrame>
     </p:spTree>
   </p:cSld>
 </p:sld>
@@ -4031,7 +4620,7 @@
             </a:pPr>
             <a:r>
               <a:rPr/>
-              <a:t>Arsitektur Round</a:t>
+              <a:t>Arsitektur Round (6 Step per Round)</a:t>
             </a:r>
           </a:p>
         </p:txBody>
@@ -4055,8 +4644,12 @@
               <a:buAutoNum type="arabicPeriod"/>
             </a:pPr>
             <a:r>
-              <a:rPr/>
+              <a:rPr b="1"/>
               <a:t>AddRoundKey</a:t>
+            </a:r>
+            <a:r>
+              <a:rPr/>
+              <a:t> — XOR state dengan round key</a:t>
             </a:r>
           </a:p>
           <a:p>
@@ -4064,8 +4657,12 @@
               <a:buAutoNum type="arabicPeriod"/>
             </a:pPr>
             <a:r>
-              <a:rPr/>
+              <a:rPr b="1"/>
               <a:t>ChaoticSubBytes</a:t>
+            </a:r>
+            <a:r>
+              <a:rPr/>
+              <a:t> — substitute byte pakai dynamic S-Box</a:t>
             </a:r>
           </a:p>
           <a:p>
@@ -4073,8 +4670,12 @@
               <a:buAutoNum type="arabicPeriod"/>
             </a:pPr>
             <a:r>
-              <a:rPr/>
+              <a:rPr b="1"/>
               <a:t>KnightPermutation</a:t>
+            </a:r>
+            <a:r>
+              <a:rPr/>
+              <a:t> — shuffle posisi byte pakai knight path</a:t>
             </a:r>
           </a:p>
           <a:p>
@@ -4082,8 +4683,12 @@
               <a:buAutoNum type="arabicPeriod"/>
             </a:pPr>
             <a:r>
-              <a:rPr/>
+              <a:rPr b="1"/>
               <a:t>BitShiftMix</a:t>
+            </a:r>
+            <a:r>
+              <a:rPr/>
+              <a:t> — rotate bit dalam setiap byte</a:t>
             </a:r>
           </a:p>
           <a:p>
@@ -4091,8 +4696,12 @@
               <a:buAutoNum type="arabicPeriod"/>
             </a:pPr>
             <a:r>
-              <a:rPr/>
+              <a:rPr b="1"/>
               <a:t>ByteDiffusion</a:t>
+            </a:r>
+            <a:r>
+              <a:rPr/>
+              <a:t> — XOR chaining antar byte (propagation)</a:t>
             </a:r>
           </a:p>
           <a:p>
@@ -4100,8 +4709,12 @@
               <a:buAutoNum type="arabicPeriod"/>
             </a:pPr>
             <a:r>
-              <a:rPr/>
+              <a:rPr b="1"/>
               <a:t>FeistelMix</a:t>
+            </a:r>
+            <a:r>
+              <a:rPr/>
+              <a:t> — pair-wise mixing 3 pass</a:t>
             </a:r>
           </a:p>
         </p:txBody>
@@ -4173,7 +4786,7 @@
             </a:pPr>
             <a:r>
               <a:rPr/>
-              <a:t>Rumus logistic map:</a:t>
+              <a:t>Logistic chaotic map:</a:t>
             </a:r>
           </a:p>
           <a:p>
@@ -4191,7 +4804,7 @@
             <a:pPr lvl="0"/>
             <a:r>
               <a:rPr/>
-              <a:t>Nilai awal </a:t>
+              <a:t>Initial value </a:t>
             </a:r>
             <a:r>
               <a:rPr>
@@ -4201,11 +4814,15 @@
             </a:r>
             <a:r>
               <a:rPr/>
-              <a:t> diturunkan dari round seed.</a:t>
+              <a:t> di-derive dari round seed.</a:t>
             </a:r>
           </a:p>
           <a:p>
             <a:pPr lvl="0"/>
+            <a:r>
+              <a:rPr/>
+              <a:t>Parameter </a:t>
+            </a:r>
             <a:r>
               <a:rPr>
                 <a:latin typeface="Courier"/>
@@ -4214,21 +4831,21 @@
             </a:r>
             <a:r>
               <a:rPr/>
-              <a:t> berubah sesuai round.</a:t>
+              <a:t> berubah per round.</a:t>
             </a:r>
           </a:p>
           <a:p>
             <a:pPr lvl="0"/>
             <a:r>
               <a:rPr/>
-              <a:t>Output chaotic digunakan untuk mengurutkan byte 0..255.</a:t>
+              <a:t>Output chaotic dipakai untuk men-sort byte 0..255.</a:t>
             </a:r>
           </a:p>
           <a:p>
             <a:pPr lvl="0"/>
             <a:r>
               <a:rPr/>
-              <a:t>Hasilnya S-Box invertibel.</a:t>
+              <a:t>Hasilnya: S-Box invertible (bisa di-reverse untuk decryption).</a:t>
             </a:r>
           </a:p>
         </p:txBody>
@@ -4298,35 +4915,35 @@
             <a:pPr lvl="0"/>
             <a:r>
               <a:rPr/>
-              <a:t>Blok 16 byte dipetakan ke papan 4x4.</a:t>
+              <a:t>Block 16 byte di-map ke board 4×4.</a:t>
             </a:r>
           </a:p>
           <a:p>
             <a:pPr lvl="0"/>
             <a:r>
               <a:rPr/>
-              <a:t>Posisi byte dipindah mengikuti langkah kuda.</a:t>
+              <a:t>Posisi byte di-shuffle mengikuti knight move (L-shape: 2+1 cell).</a:t>
             </a:r>
           </a:p>
           <a:p>
             <a:pPr lvl="0"/>
             <a:r>
               <a:rPr/>
-              <a:t>Titik awal ditentukan round seed.</a:t>
+              <a:t>Starting position ditentukan round seed.</a:t>
             </a:r>
           </a:p>
           <a:p>
             <a:pPr lvl="0"/>
             <a:r>
               <a:rPr/>
-              <a:t>Tie-breaking juga dipengaruhi round seed.</a:t>
+              <a:t>Selection: Warnsdorff’s heuristic (min onward moves).</a:t>
             </a:r>
           </a:p>
           <a:p>
             <a:pPr lvl="0"/>
             <a:r>
               <a:rPr/>
-              <a:t>Hasil: permutasi non-linear dan mudah divisualisasikan.</a:t>
+              <a:t>Tie-breaking menggunakan round seed.</a:t>
             </a:r>
           </a:p>
         </p:txBody>
@@ -4373,7 +4990,7 @@
             </a:pPr>
             <a:r>
               <a:rPr/>
-              <a:t>Difusi dan Chaining</a:t>
+              <a:t>Diffusion dan Chaining</a:t>
             </a:r>
           </a:p>
         </p:txBody>
@@ -4395,29 +5012,52 @@
           <a:p>
             <a:pPr lvl="0"/>
             <a:r>
-              <a:rPr/>
-              <a:t>Byte rotation menyebarkan bit di dalam byte.</a:t>
+              <a:rPr b="1"/>
+              <a:t>BitShiftMix:</a:t>
+            </a:r>
+            <a:r>
+              <a:rPr/>
+              <a:t> rotate bit di dalam byte → spread intra-byte.</a:t>
             </a:r>
           </a:p>
           <a:p>
             <a:pPr lvl="0"/>
             <a:r>
-              <a:rPr/>
-              <a:t>ByteDiffusion dan FeistelMix menyebarkan perubahan antarbyte.</a:t>
+              <a:rPr b="1"/>
+              <a:t>ByteDiffusion:</a:t>
+            </a:r>
+            <a:r>
+              <a:rPr/>
+              <a:t> XOR chaining → 1 byte berubah, propagate ke semua byte setelahnya.</a:t>
             </a:r>
           </a:p>
           <a:p>
             <a:pPr lvl="0"/>
             <a:r>
-              <a:rPr/>
-              <a:t>Mode chaining membuat blok berikutnya dipengaruhi ciphertext sebelumnya.</a:t>
+              <a:rPr b="1"/>
+              <a:t>FeistelMix:</a:t>
+            </a:r>
+            <a:r>
+              <a:rPr/>
+              <a:t> pair-wise mixing 3 pass → strengthen avalanche.</a:t>
             </a:r>
           </a:p>
           <a:p>
             <a:pPr lvl="0"/>
             <a:r>
-              <a:rPr/>
-              <a:t>Dekripsi tetap bisa dilakukan karena semua transformasi invertibel.</a:t>
+              <a:rPr b="1"/>
+              <a:t>CBC mode:</a:t>
+            </a:r>
+            <a:r>
+              <a:rPr/>
+              <a:t> block berikutnya di-XOR dengan ciphertext block sebelumnya.</a:t>
+            </a:r>
+          </a:p>
+          <a:p>
+            <a:pPr lvl="0"/>
+            <a:r>
+              <a:rPr/>
+              <a:t>Semua operation invertible → decryption tetap possible.</a:t>
             </a:r>
           </a:p>
         </p:txBody>
@@ -4464,65 +5104,329 @@
             </a:pPr>
             <a:r>
               <a:rPr/>
-              <a:t>Hasil Demo Python</a:t>
-            </a:r>
-          </a:p>
-        </p:txBody>
-      </p:sp>
-      <p:sp>
-        <p:nvSpPr>
-          <p:cNvPr id="3" name="Content Placeholder 2"/>
-          <p:cNvSpPr>
-            <a:spLocks noGrp="1"/>
-          </p:cNvSpPr>
+              <a:t>Tech Stack</a:t>
+            </a:r>
+          </a:p>
+        </p:txBody>
+      </p:sp>
+      <p:graphicFrame>
+        <p:nvGraphicFramePr>
+          <p:cNvPr id="6" name="Content Placeholder 5"/>
+          <p:cNvGraphicFramePr>
+            <a:graphicFrameLocks noGrp="1"/>
+          </p:cNvGraphicFramePr>
           <p:nvPr>
             <p:ph idx="1"/>
           </p:nvPr>
-        </p:nvSpPr>
-        <p:spPr/>
-        <p:txBody>
-          <a:bodyPr/>
-          <a:lstStyle/>
-          <a:p>
-            <a:pPr lvl="0"/>
-            <a:r>
-              <a:rPr/>
-              <a:t>Plaintext berhasil dienkripsi.</a:t>
-            </a:r>
-          </a:p>
-          <a:p>
-            <a:pPr lvl="0"/>
-            <a:r>
-              <a:rPr/>
-              <a:t>Ciphertext ditampilkan dalam hex dan base64.</a:t>
-            </a:r>
-          </a:p>
-          <a:p>
-            <a:pPr lvl="0"/>
-            <a:r>
-              <a:rPr/>
-              <a:t>Dekripsi mengembalikan plaintext asli.</a:t>
-            </a:r>
-          </a:p>
-          <a:p>
-            <a:pPr lvl="0"/>
-            <a:r>
-              <a:rPr/>
-              <a:t>Bukti utama: </a:t>
-            </a:r>
-            <a:r>
-              <a:rPr>
-                <a:latin typeface="Courier"/>
-              </a:rPr>
-              <a:t>Decryption OK: True</a:t>
-            </a:r>
-            <a:r>
-              <a:rPr/>
-              <a:t>.</a:t>
-            </a:r>
-          </a:p>
-        </p:txBody>
-      </p:sp>
+        </p:nvGraphicFramePr>
+        <p:xfrm>
+          <a:off x="457200" y="1193800"/>
+          <a:ext cx="8229600" cy="3390900"/>
+        </p:xfrm>
+        <a:graphic>
+          <a:graphicData uri="http://schemas.openxmlformats.org/drawingml/2006/table">
+            <a:tbl>
+              <a:tblPr firstRow="1" bandRow="1">
+                <a:tableStyleId>{5C22544A-7EE6-4342-B048-85BDC9FD1C3A}</a:tableStyleId>
+              </a:tblPr>
+              <a:tblGrid>
+                <a:gridCol w="4114800"/>
+                <a:gridCol w="4114800"/>
+              </a:tblGrid>
+              <a:tr h="0">
+                <a:tc>
+                  <a:txBody>
+                    <a:bodyPr/>
+                    <a:lstStyle/>
+                    <a:p>
+                      <a:pPr lvl="0" indent="0" marL="0">
+                        <a:buNone/>
+                      </a:pPr>
+                      <a:r>
+                        <a:rPr/>
+                        <a:t>Parameter</a:t>
+                      </a:r>
+                    </a:p>
+                  </a:txBody>
+                  <a:tcPr/>
+                </a:tc>
+                <a:tc>
+                  <a:txBody>
+                    <a:bodyPr/>
+                    <a:lstStyle/>
+                    <a:p>
+                      <a:pPr lvl="0" indent="0" marL="0">
+                        <a:buNone/>
+                      </a:pPr>
+                      <a:r>
+                        <a:rPr/>
+                        <a:t>Value</a:t>
+                      </a:r>
+                    </a:p>
+                  </a:txBody>
+                  <a:tcPr/>
+                </a:tc>
+              </a:tr>
+              <a:tr h="0">
+                <a:tc>
+                  <a:txBody>
+                    <a:bodyPr/>
+                    <a:lstStyle/>
+                    <a:p>
+                      <a:pPr lvl="0" indent="0" marL="0">
+                        <a:buNone/>
+                      </a:pPr>
+                      <a:r>
+                        <a:rPr/>
+                        <a:t>Algorithm</a:t>
+                      </a:r>
+                    </a:p>
+                  </a:txBody>
+                </a:tc>
+                <a:tc>
+                  <a:txBody>
+                    <a:bodyPr/>
+                    <a:lstStyle/>
+                    <a:p>
+                      <a:pPr lvl="0" indent="0" marL="0">
+                        <a:buNone/>
+                      </a:pPr>
+                      <a:r>
+                        <a:rPr/>
+                        <a:t>KCC-128 (Block Cipher)</a:t>
+                      </a:r>
+                    </a:p>
+                  </a:txBody>
+                </a:tc>
+              </a:tr>
+              <a:tr h="0">
+                <a:tc>
+                  <a:txBody>
+                    <a:bodyPr/>
+                    <a:lstStyle/>
+                    <a:p>
+                      <a:pPr lvl="0" indent="0" marL="0">
+                        <a:buNone/>
+                      </a:pPr>
+                      <a:r>
+                        <a:rPr/>
+                        <a:t>Block Size</a:t>
+                      </a:r>
+                    </a:p>
+                  </a:txBody>
+                </a:tc>
+                <a:tc>
+                  <a:txBody>
+                    <a:bodyPr/>
+                    <a:lstStyle/>
+                    <a:p>
+                      <a:pPr lvl="0" indent="0" marL="0">
+                        <a:buNone/>
+                      </a:pPr>
+                      <a:r>
+                        <a:rPr/>
+                        <a:t>128 bit (16 byte, matrix 4×4)</a:t>
+                      </a:r>
+                    </a:p>
+                  </a:txBody>
+                </a:tc>
+              </a:tr>
+              <a:tr h="0">
+                <a:tc>
+                  <a:txBody>
+                    <a:bodyPr/>
+                    <a:lstStyle/>
+                    <a:p>
+                      <a:pPr lvl="0" indent="0" marL="0">
+                        <a:buNone/>
+                      </a:pPr>
+                      <a:r>
+                        <a:rPr/>
+                        <a:t>Rounds</a:t>
+                      </a:r>
+                    </a:p>
+                  </a:txBody>
+                </a:tc>
+                <a:tc>
+                  <a:txBody>
+                    <a:bodyPr/>
+                    <a:lstStyle/>
+                    <a:p>
+                      <a:pPr lvl="0" indent="0" marL="0">
+                        <a:buNone/>
+                      </a:pPr>
+                      <a:r>
+                        <a:rPr/>
+                        <a:t>10</a:t>
+                      </a:r>
+                    </a:p>
+                  </a:txBody>
+                </a:tc>
+              </a:tr>
+              <a:tr h="0">
+                <a:tc>
+                  <a:txBody>
+                    <a:bodyPr/>
+                    <a:lstStyle/>
+                    <a:p>
+                      <a:pPr lvl="0" indent="0" marL="0">
+                        <a:buNone/>
+                      </a:pPr>
+                      <a:r>
+                        <a:rPr/>
+                        <a:t>S-Box</a:t>
+                      </a:r>
+                    </a:p>
+                  </a:txBody>
+                </a:tc>
+                <a:tc>
+                  <a:txBody>
+                    <a:bodyPr/>
+                    <a:lstStyle/>
+                    <a:p>
+                      <a:pPr lvl="0" indent="0" marL="0">
+                        <a:buNone/>
+                      </a:pPr>
+                      <a:r>
+                        <a:rPr/>
+                        <a:t>Logistic Chaotic Map (dynamic/round)</a:t>
+                      </a:r>
+                    </a:p>
+                  </a:txBody>
+                </a:tc>
+              </a:tr>
+              <a:tr h="0">
+                <a:tc>
+                  <a:txBody>
+                    <a:bodyPr/>
+                    <a:lstStyle/>
+                    <a:p>
+                      <a:pPr lvl="0" indent="0" marL="0">
+                        <a:buNone/>
+                      </a:pPr>
+                      <a:r>
+                        <a:rPr/>
+                        <a:t>Permutation</a:t>
+                      </a:r>
+                    </a:p>
+                  </a:txBody>
+                </a:tc>
+                <a:tc>
+                  <a:txBody>
+                    <a:bodyPr/>
+                    <a:lstStyle/>
+                    <a:p>
+                      <a:pPr lvl="0" indent="0" marL="0">
+                        <a:buNone/>
+                      </a:pPr>
+                      <a:r>
+                        <a:rPr/>
+                        <a:t>Knight’s Tour (Warnsdorff)</a:t>
+                      </a:r>
+                    </a:p>
+                  </a:txBody>
+                </a:tc>
+              </a:tr>
+              <a:tr h="0">
+                <a:tc>
+                  <a:txBody>
+                    <a:bodyPr/>
+                    <a:lstStyle/>
+                    <a:p>
+                      <a:pPr lvl="0" indent="0" marL="0">
+                        <a:buNone/>
+                      </a:pPr>
+                      <a:r>
+                        <a:rPr/>
+                        <a:t>Mode</a:t>
+                      </a:r>
+                    </a:p>
+                  </a:txBody>
+                </a:tc>
+                <a:tc>
+                  <a:txBody>
+                    <a:bodyPr/>
+                    <a:lstStyle/>
+                    <a:p>
+                      <a:pPr lvl="0" indent="0" marL="0">
+                        <a:buNone/>
+                      </a:pPr>
+                      <a:r>
+                        <a:rPr/>
+                        <a:t>CBC (Cipher Block Chaining)</a:t>
+                      </a:r>
+                    </a:p>
+                  </a:txBody>
+                </a:tc>
+              </a:tr>
+              <a:tr h="0">
+                <a:tc>
+                  <a:txBody>
+                    <a:bodyPr/>
+                    <a:lstStyle/>
+                    <a:p>
+                      <a:pPr lvl="0" indent="0" marL="0">
+                        <a:buNone/>
+                      </a:pPr>
+                      <a:r>
+                        <a:rPr/>
+                        <a:t>Key Schedule</a:t>
+                      </a:r>
+                    </a:p>
+                  </a:txBody>
+                </a:tc>
+                <a:tc>
+                  <a:txBody>
+                    <a:bodyPr/>
+                    <a:lstStyle/>
+                    <a:p>
+                      <a:pPr lvl="0" indent="0" marL="0">
+                        <a:buNone/>
+                      </a:pPr>
+                      <a:r>
+                        <a:rPr/>
+                        <a:t>SHA-256</a:t>
+                      </a:r>
+                    </a:p>
+                  </a:txBody>
+                </a:tc>
+              </a:tr>
+              <a:tr h="0">
+                <a:tc>
+                  <a:txBody>
+                    <a:bodyPr/>
+                    <a:lstStyle/>
+                    <a:p>
+                      <a:pPr lvl="0" indent="0" marL="0">
+                        <a:buNone/>
+                      </a:pPr>
+                      <a:r>
+                        <a:rPr/>
+                        <a:t>Padding</a:t>
+                      </a:r>
+                    </a:p>
+                  </a:txBody>
+                </a:tc>
+                <a:tc>
+                  <a:txBody>
+                    <a:bodyPr/>
+                    <a:lstStyle/>
+                    <a:p>
+                      <a:pPr lvl="0" indent="0" marL="0">
+                        <a:buNone/>
+                      </a:pPr>
+                      <a:r>
+                        <a:rPr/>
+                        <a:t>PKCS#7</a:t>
+                      </a:r>
+                    </a:p>
+                  </a:txBody>
+                </a:tc>
+              </a:tr>
+            </a:tbl>
+          </a:graphicData>
+        </a:graphic>
+      </p:graphicFrame>
     </p:spTree>
   </p:cSld>
 </p:sld>

</xml_diff>

<commit_message>
Refresh report slides and demo walkthrough
</commit_message>
<xml_diff>
--- a/slides/slides-knight-chaos-cipher.pptx
+++ b/slides/slides-knight-chaos-cipher.pptx
@@ -18,9 +18,6 @@
     <p:sldId id="266" r:id="rId12"/>
     <p:sldId id="267" r:id="rId13"/>
     <p:sldId id="268" r:id="rId14"/>
-    <p:sldId id="269" r:id="rId15"/>
-    <p:sldId id="270" r:id="rId16"/>
-    <p:sldId id="271" r:id="rId17"/>
   </p:sldIdLst>
   <p:sldSz cx="9144000" cy="5143500" type="screen16x9"/>
   <p:notesSz cx="6858000" cy="9144000"/>
@@ -3584,7 +3581,7 @@
             </a:pPr>
             <a:r>
               <a:rPr/>
-              <a:t>Demo Interaktif</a:t>
+              <a:t>Keterbatasan</a:t>
             </a:r>
           </a:p>
         </p:txBody>
@@ -3607,68 +3604,28 @@
             <a:pPr lvl="0"/>
             <a:r>
               <a:rPr/>
-              <a:t>File: </a:t>
-            </a:r>
-            <a:r>
-              <a:rPr>
-                <a:latin typeface="Courier"/>
-              </a:rPr>
-              <a:t>demo/index.html</a:t>
+              <a:t>IV di-derive deterministic dari key (idealnya random).</a:t>
             </a:r>
           </a:p>
           <a:p>
             <a:pPr lvl="0"/>
             <a:r>
-              <a:rPr b="1"/>
-              <a:t>Block selector</a:t>
-            </a:r>
-            <a:r>
-              <a:rPr/>
-              <a:t> — pilih block mana yang mau dilihat.</a:t>
+              <a:rPr/>
+              <a:t>Belum ada MAC/HMAC (hanya confidentiality, belum integrity).</a:t>
             </a:r>
           </a:p>
           <a:p>
             <a:pPr lvl="0"/>
             <a:r>
-              <a:rPr b="1"/>
-              <a:t>Matrix 4×4</a:t>
-            </a:r>
-            <a:r>
-              <a:rPr/>
-              <a:t> — klik cell untuk lihat hitung manual byte tersebut.</a:t>
+              <a:rPr/>
+              <a:t>S-Box nonlinearity dan differential uniformity belum diuji formal.</a:t>
             </a:r>
           </a:p>
           <a:p>
             <a:pPr lvl="0"/>
             <a:r>
-              <a:rPr b="1"/>
-              <a:t>Detail panel</a:t>
-            </a:r>
-            <a:r>
-              <a:rPr/>
-              <a:t> — menampilkan XOR biner, S-Box lookup, rotation, per byte.</a:t>
-            </a:r>
-          </a:p>
-          <a:p>
-            <a:pPr lvl="0"/>
-            <a:r>
-              <a:rPr b="1"/>
-              <a:t>Assembly view</a:t>
-            </a:r>
-            <a:r>
-              <a:rPr/>
-              <a:t> — menampilkan bagaimana block-block digabung jadi ciphertext final.</a:t>
-            </a:r>
-          </a:p>
-          <a:p>
-            <a:pPr lvl="0"/>
-            <a:r>
-              <a:rPr b="1"/>
-              <a:t>Timeline</a:t>
-            </a:r>
-            <a:r>
-              <a:rPr/>
-              <a:t> — navigasi step-by-step per round.</a:t>
+              <a:rPr/>
+              <a:t>Pengujian perlu diperluas dengan dataset yang lebih besar.</a:t>
             </a:r>
           </a:p>
         </p:txBody>
@@ -3715,7 +3672,7 @@
             </a:pPr>
             <a:r>
               <a:rPr/>
-              <a:t>Fitur Demo</a:t>
+              <a:t>Kesimpulan</a:t>
             </a:r>
           </a:p>
         </p:txBody>
@@ -3735,380 +3692,31 @@
           <a:bodyPr/>
           <a:lstStyle/>
           <a:p>
-            <a:pPr lvl="0" indent="-342900" marL="342900">
-              <a:buAutoNum type="arabicPeriod"/>
-            </a:pPr>
-            <a:r>
-              <a:rPr/>
-              <a:t>Konversi plaintext → byte (tabel ASCII lengkap)</a:t>
-            </a:r>
-          </a:p>
-          <a:p>
-            <a:pPr lvl="0" indent="-342900" marL="342900">
-              <a:buAutoNum type="arabicPeriod"/>
-            </a:pPr>
-            <a:r>
-              <a:rPr/>
-              <a:t>Hitung manual per byte (dynamic, klik cell manapun)</a:t>
-            </a:r>
-          </a:p>
-          <a:p>
-            <a:pPr lvl="0" indent="-342900" marL="342900">
-              <a:buAutoNum type="arabicPeriod"/>
-            </a:pPr>
-            <a:r>
-              <a:rPr/>
-              <a:t>Visualisasi round key, S-Box mapping, knight path</a:t>
-            </a:r>
-          </a:p>
-          <a:p>
-            <a:pPr lvl="0" indent="-342900" marL="342900">
-              <a:buAutoNum type="arabicPeriod"/>
-            </a:pPr>
-            <a:r>
-              <a:rPr/>
-              <a:t>Block selector untuk multi-block plaintext</a:t>
-            </a:r>
-          </a:p>
-          <a:p>
-            <a:pPr lvl="0" indent="-342900" marL="342900">
-              <a:buAutoNum type="arabicPeriod"/>
-            </a:pPr>
-            <a:r>
-              <a:rPr/>
-              <a:t>Concat visualization: block 1 + block 2 + … = ciphertext</a:t>
-            </a:r>
-          </a:p>
-        </p:txBody>
-      </p:sp>
-    </p:spTree>
-  </p:cSld>
-</p:sld>
-</file>
-
-<file path=ppt/slides/slide14.xml><?xml version="1.0" encoding="utf-8"?>
-<p:sld xmlns:a="http://schemas.openxmlformats.org/drawingml/2006/main" xmlns:r="http://schemas.openxmlformats.org/officeDocument/2006/relationships" xmlns:p="http://schemas.openxmlformats.org/presentationml/2006/main">
-  <p:cSld>
-    <p:spTree>
-      <p:nvGrpSpPr>
-        <p:cNvPr id="1" name=""/>
-        <p:cNvGrpSpPr/>
-        <p:nvPr/>
-      </p:nvGrpSpPr>
-      <p:grpSpPr>
-        <a:xfrm>
-          <a:off x="0" y="0"/>
-          <a:ext cx="0" cy="0"/>
-          <a:chOff x="0" y="0"/>
-          <a:chExt cx="0" cy="0"/>
-        </a:xfrm>
-      </p:grpSpPr>
-      <p:sp>
-        <p:nvSpPr>
-          <p:cNvPr id="2" name="Title 1"/>
-          <p:cNvSpPr>
-            <a:spLocks noGrp="1"/>
-          </p:cNvSpPr>
-          <p:nvPr>
-            <p:ph type="title"/>
-          </p:nvPr>
-        </p:nvSpPr>
-        <p:spPr/>
-        <p:txBody>
-          <a:bodyPr/>
-          <a:lstStyle/>
-          <a:p>
-            <a:pPr lvl="0" indent="0" marL="0">
-              <a:buNone/>
-            </a:pPr>
-            <a:r>
-              <a:rPr/>
-              <a:t>Keterbatasan</a:t>
-            </a:r>
-          </a:p>
-        </p:txBody>
-      </p:sp>
-      <p:sp>
-        <p:nvSpPr>
-          <p:cNvPr id="3" name="Content Placeholder 2"/>
-          <p:cNvSpPr>
-            <a:spLocks noGrp="1"/>
-          </p:cNvSpPr>
-          <p:nvPr>
-            <p:ph idx="1"/>
-          </p:nvPr>
-        </p:nvSpPr>
-        <p:spPr/>
-        <p:txBody>
-          <a:bodyPr/>
-          <a:lstStyle/>
-          <a:p>
             <a:pPr lvl="0"/>
             <a:r>
               <a:rPr/>
-              <a:t>IV di-derive deterministic dari key (idealnya random).</a:t>
+              <a:t>KCC-128 memodifikasi substitution, permutation, diffusion, dan key schedule.</a:t>
             </a:r>
           </a:p>
           <a:p>
             <a:pPr lvl="0"/>
             <a:r>
               <a:rPr/>
-              <a:t>Belum ada MAC/HMAC (hanya confidentiality, belum integrity).</a:t>
+              <a:t>Knight’s tour sebagai permutation → non-linear, game-based.</a:t>
             </a:r>
           </a:p>
           <a:p>
             <a:pPr lvl="0"/>
             <a:r>
               <a:rPr/>
-              <a:t>S-Box nonlinearity dan differential uniformity belum diuji formal.</a:t>
+              <a:t>Chaotic map sebagai S-Box generator → dynamic per round.</a:t>
             </a:r>
           </a:p>
           <a:p>
             <a:pPr lvl="0"/>
             <a:r>
               <a:rPr/>
-              <a:t>Pengujian perlu diperluas dengan dataset yang lebih besar.</a:t>
-            </a:r>
-          </a:p>
-        </p:txBody>
-      </p:sp>
-    </p:spTree>
-  </p:cSld>
-</p:sld>
-</file>
-
-<file path=ppt/slides/slide15.xml><?xml version="1.0" encoding="utf-8"?>
-<p:sld xmlns:a="http://schemas.openxmlformats.org/drawingml/2006/main" xmlns:r="http://schemas.openxmlformats.org/officeDocument/2006/relationships" xmlns:p="http://schemas.openxmlformats.org/presentationml/2006/main">
-  <p:cSld>
-    <p:spTree>
-      <p:nvGrpSpPr>
-        <p:cNvPr id="1" name=""/>
-        <p:cNvGrpSpPr/>
-        <p:nvPr/>
-      </p:nvGrpSpPr>
-      <p:grpSpPr>
-        <a:xfrm>
-          <a:off x="0" y="0"/>
-          <a:ext cx="0" cy="0"/>
-          <a:chOff x="0" y="0"/>
-          <a:chExt cx="0" cy="0"/>
-        </a:xfrm>
-      </p:grpSpPr>
-      <p:sp>
-        <p:nvSpPr>
-          <p:cNvPr id="2" name="Title 1"/>
-          <p:cNvSpPr>
-            <a:spLocks noGrp="1"/>
-          </p:cNvSpPr>
-          <p:nvPr>
-            <p:ph type="title"/>
-          </p:nvPr>
-        </p:nvSpPr>
-        <p:spPr/>
-        <p:txBody>
-          <a:bodyPr/>
-          <a:lstStyle/>
-          <a:p>
-            <a:pPr lvl="0" indent="0" marL="0">
-              <a:buNone/>
-            </a:pPr>
-            <a:r>
-              <a:rPr/>
-              <a:t>Kesimpulan</a:t>
-            </a:r>
-          </a:p>
-        </p:txBody>
-      </p:sp>
-      <p:sp>
-        <p:nvSpPr>
-          <p:cNvPr id="3" name="Content Placeholder 2"/>
-          <p:cNvSpPr>
-            <a:spLocks noGrp="1"/>
-          </p:cNvSpPr>
-          <p:nvPr>
-            <p:ph idx="1"/>
-          </p:nvPr>
-        </p:nvSpPr>
-        <p:spPr/>
-        <p:txBody>
-          <a:bodyPr/>
-          <a:lstStyle/>
-          <a:p>
-            <a:pPr lvl="0"/>
-            <a:r>
-              <a:rPr/>
-              <a:t>KCC-128 memodifikasi substitution, permutation, diffusion, dan key schedule.</a:t>
-            </a:r>
-          </a:p>
-          <a:p>
-            <a:pPr lvl="0"/>
-            <a:r>
-              <a:rPr/>
-              <a:t>Knight’s tour sebagai permutation → non-linear, game-based.</a:t>
-            </a:r>
-          </a:p>
-          <a:p>
-            <a:pPr lvl="0"/>
-            <a:r>
-              <a:rPr/>
-              <a:t>Chaotic map sebagai S-Box generator → dynamic per round.</a:t>
-            </a:r>
-          </a:p>
-          <a:p>
-            <a:pPr lvl="0"/>
-            <a:r>
-              <a:rPr/>
               <a:t>Encryption-decryption bekerja benar, avalanche ~50%.</a:t>
-            </a:r>
-          </a:p>
-          <a:p>
-            <a:pPr lvl="0"/>
-            <a:r>
-              <a:rPr/>
-              <a:t>Demo interaktif menampilkan proses manual step-by-step.</a:t>
-            </a:r>
-          </a:p>
-        </p:txBody>
-      </p:sp>
-    </p:spTree>
-  </p:cSld>
-</p:sld>
-</file>
-
-<file path=ppt/slides/slide16.xml><?xml version="1.0" encoding="utf-8"?>
-<p:sld xmlns:a="http://schemas.openxmlformats.org/drawingml/2006/main" xmlns:r="http://schemas.openxmlformats.org/officeDocument/2006/relationships" xmlns:p="http://schemas.openxmlformats.org/presentationml/2006/main">
-  <p:cSld>
-    <p:spTree>
-      <p:nvGrpSpPr>
-        <p:cNvPr id="1" name=""/>
-        <p:cNvGrpSpPr/>
-        <p:nvPr/>
-      </p:nvGrpSpPr>
-      <p:grpSpPr>
-        <a:xfrm>
-          <a:off x="0" y="0"/>
-          <a:ext cx="0" cy="0"/>
-          <a:chOff x="0" y="0"/>
-          <a:chExt cx="0" cy="0"/>
-        </a:xfrm>
-      </p:grpSpPr>
-      <p:sp>
-        <p:nvSpPr>
-          <p:cNvPr id="2" name="Title 1"/>
-          <p:cNvSpPr>
-            <a:spLocks noGrp="1"/>
-          </p:cNvSpPr>
-          <p:nvPr>
-            <p:ph type="title"/>
-          </p:nvPr>
-        </p:nvSpPr>
-        <p:spPr/>
-        <p:txBody>
-          <a:bodyPr/>
-          <a:lstStyle/>
-          <a:p>
-            <a:pPr lvl="0" indent="0" marL="0">
-              <a:buNone/>
-            </a:pPr>
-            <a:r>
-              <a:rPr/>
-              <a:t>Live Demo</a:t>
-            </a:r>
-          </a:p>
-        </p:txBody>
-      </p:sp>
-      <p:sp>
-        <p:nvSpPr>
-          <p:cNvPr id="3" name="Content Placeholder 2"/>
-          <p:cNvSpPr>
-            <a:spLocks noGrp="1"/>
-          </p:cNvSpPr>
-          <p:nvPr>
-            <p:ph idx="1"/>
-          </p:nvPr>
-        </p:nvSpPr>
-        <p:spPr/>
-        <p:txBody>
-          <a:bodyPr/>
-          <a:lstStyle/>
-          <a:p>
-            <a:pPr lvl="0" indent="-342900" marL="342900">
-              <a:buAutoNum type="arabicPeriod"/>
-            </a:pPr>
-            <a:r>
-              <a:rPr/>
-              <a:t>Buka </a:t>
-            </a:r>
-            <a:r>
-              <a:rPr>
-                <a:latin typeface="Courier"/>
-              </a:rPr>
-              <a:t>demo/index.html</a:t>
-            </a:r>
-            <a:r>
-              <a:rPr/>
-              <a:t> di browser.</a:t>
-            </a:r>
-          </a:p>
-          <a:p>
-            <a:pPr lvl="0" indent="-342900" marL="342900">
-              <a:buAutoNum type="arabicPeriod"/>
-            </a:pPr>
-            <a:r>
-              <a:rPr/>
-              <a:t>Masukkan plaintext dan key.</a:t>
-            </a:r>
-          </a:p>
-          <a:p>
-            <a:pPr lvl="0" indent="-342900" marL="342900">
-              <a:buAutoNum type="arabicPeriod"/>
-            </a:pPr>
-            <a:r>
-              <a:rPr/>
-              <a:t>Klik </a:t>
-            </a:r>
-            <a:r>
-              <a:rPr b="1"/>
-              <a:t>Encrypt &amp; Animate</a:t>
-            </a:r>
-            <a:r>
-              <a:rPr/>
-              <a:t>.</a:t>
-            </a:r>
-          </a:p>
-          <a:p>
-            <a:pPr lvl="0" indent="-342900" marL="342900">
-              <a:buAutoNum type="arabicPeriod"/>
-            </a:pPr>
-            <a:r>
-              <a:rPr/>
-              <a:t>Pilih block dari dropdown.</a:t>
-            </a:r>
-          </a:p>
-          <a:p>
-            <a:pPr lvl="0" indent="-342900" marL="342900">
-              <a:buAutoNum type="arabicPeriod"/>
-            </a:pPr>
-            <a:r>
-              <a:rPr/>
-              <a:t>Klik cell di matrix → lihat hitung manual.</a:t>
-            </a:r>
-          </a:p>
-          <a:p>
-            <a:pPr lvl="0" indent="-342900" marL="342900">
-              <a:buAutoNum type="arabicPeriod"/>
-            </a:pPr>
-            <a:r>
-              <a:rPr/>
-              <a:t>Navigasi step dengan </a:t>
-            </a:r>
-            <a:r>
-              <a:rPr b="1"/>
-              <a:t>Prev / Play / Next</a:t>
-            </a:r>
-            <a:r>
-              <a:rPr/>
-              <a:t>.</a:t>
             </a:r>
           </a:p>
         </p:txBody>

</xml_diff>